<commit_message>
added the zip file
</commit_message>
<xml_diff>
--- a/DataAnalysis_ElectricVehicles.pptx
+++ b/DataAnalysis_ElectricVehicles.pptx
@@ -822,7 +822,7 @@
   <p:cSld>
     <p:spTree>
       <p:nvGrpSpPr>
-        <p:cNvPr id="118" name="Shape 118"/>
+        <p:cNvPr id="120" name="Shape 120"/>
         <p:cNvGrpSpPr/>
         <p:nvPr/>
       </p:nvGrpSpPr>
@@ -836,7 +836,7 @@
       </p:grpSpPr>
       <p:sp>
         <p:nvSpPr>
-          <p:cNvPr id="119" name="Google Shape;119;g35da4827f45_0_81:notes"/>
+          <p:cNvPr id="121" name="Google Shape;121;g35da4827f45_0_81:notes"/>
           <p:cNvSpPr/>
           <p:nvPr>
             <p:ph idx="2" type="sldImg"/>
@@ -871,7 +871,7 @@
       </p:sp>
       <p:sp>
         <p:nvSpPr>
-          <p:cNvPr id="120" name="Google Shape;120;g35da4827f45_0_81:notes"/>
+          <p:cNvPr id="122" name="Google Shape;122;g35da4827f45_0_81:notes"/>
           <p:cNvSpPr txBox="1"/>
           <p:nvPr>
             <p:ph idx="1" type="body"/>
@@ -921,7 +921,7 @@
   <p:cSld>
     <p:spTree>
       <p:nvGrpSpPr>
-        <p:cNvPr id="126" name="Shape 126"/>
+        <p:cNvPr id="128" name="Shape 128"/>
         <p:cNvGrpSpPr/>
         <p:nvPr/>
       </p:nvGrpSpPr>
@@ -935,7 +935,7 @@
       </p:grpSpPr>
       <p:sp>
         <p:nvSpPr>
-          <p:cNvPr id="127" name="Google Shape;127;g35da4827f45_0_76:notes"/>
+          <p:cNvPr id="129" name="Google Shape;129;g35da4827f45_0_76:notes"/>
           <p:cNvSpPr/>
           <p:nvPr>
             <p:ph idx="2" type="sldImg"/>
@@ -970,7 +970,7 @@
       </p:sp>
       <p:sp>
         <p:nvSpPr>
-          <p:cNvPr id="128" name="Google Shape;128;g35da4827f45_0_76:notes"/>
+          <p:cNvPr id="130" name="Google Shape;130;g35da4827f45_0_76:notes"/>
           <p:cNvSpPr txBox="1"/>
           <p:nvPr>
             <p:ph idx="1" type="body"/>
@@ -1020,7 +1020,7 @@
   <p:cSld>
     <p:spTree>
       <p:nvGrpSpPr>
-        <p:cNvPr id="133" name="Shape 133"/>
+        <p:cNvPr id="135" name="Shape 135"/>
         <p:cNvGrpSpPr/>
         <p:nvPr/>
       </p:nvGrpSpPr>
@@ -1034,7 +1034,7 @@
       </p:grpSpPr>
       <p:sp>
         <p:nvSpPr>
-          <p:cNvPr id="134" name="Google Shape;134;g35da4827f45_0_86:notes"/>
+          <p:cNvPr id="136" name="Google Shape;136;g35da4827f45_0_86:notes"/>
           <p:cNvSpPr/>
           <p:nvPr>
             <p:ph idx="2" type="sldImg"/>
@@ -1069,7 +1069,7 @@
       </p:sp>
       <p:sp>
         <p:nvSpPr>
-          <p:cNvPr id="135" name="Google Shape;135;g35da4827f45_0_86:notes"/>
+          <p:cNvPr id="137" name="Google Shape;137;g35da4827f45_0_86:notes"/>
           <p:cNvSpPr txBox="1"/>
           <p:nvPr>
             <p:ph idx="1" type="body"/>
@@ -1119,7 +1119,7 @@
   <p:cSld>
     <p:spTree>
       <p:nvGrpSpPr>
-        <p:cNvPr id="140" name="Shape 140"/>
+        <p:cNvPr id="142" name="Shape 142"/>
         <p:cNvGrpSpPr/>
         <p:nvPr/>
       </p:nvGrpSpPr>
@@ -1133,7 +1133,7 @@
       </p:grpSpPr>
       <p:sp>
         <p:nvSpPr>
-          <p:cNvPr id="141" name="Google Shape;141;g35da4827f45_0_180:notes"/>
+          <p:cNvPr id="143" name="Google Shape;143;g35da4827f45_0_180:notes"/>
           <p:cNvSpPr/>
           <p:nvPr>
             <p:ph idx="2" type="sldImg"/>
@@ -1168,7 +1168,7 @@
       </p:sp>
       <p:sp>
         <p:nvSpPr>
-          <p:cNvPr id="142" name="Google Shape;142;g35da4827f45_0_180:notes"/>
+          <p:cNvPr id="144" name="Google Shape;144;g35da4827f45_0_180:notes"/>
           <p:cNvSpPr txBox="1"/>
           <p:nvPr>
             <p:ph idx="1" type="body"/>
@@ -1218,7 +1218,7 @@
   <p:cSld>
     <p:spTree>
       <p:nvGrpSpPr>
-        <p:cNvPr id="148" name="Shape 148"/>
+        <p:cNvPr id="150" name="Shape 150"/>
         <p:cNvGrpSpPr/>
         <p:nvPr/>
       </p:nvGrpSpPr>
@@ -1232,7 +1232,7 @@
       </p:grpSpPr>
       <p:sp>
         <p:nvSpPr>
-          <p:cNvPr id="149" name="Google Shape;149;g35da4827f45_0_116:notes"/>
+          <p:cNvPr id="151" name="Google Shape;151;g35da4827f45_0_116:notes"/>
           <p:cNvSpPr/>
           <p:nvPr>
             <p:ph idx="2" type="sldImg"/>
@@ -1267,7 +1267,7 @@
       </p:sp>
       <p:sp>
         <p:nvSpPr>
-          <p:cNvPr id="150" name="Google Shape;150;g35da4827f45_0_116:notes"/>
+          <p:cNvPr id="152" name="Google Shape;152;g35da4827f45_0_116:notes"/>
           <p:cNvSpPr txBox="1"/>
           <p:nvPr>
             <p:ph idx="1" type="body"/>
@@ -1317,7 +1317,7 @@
   <p:cSld>
     <p:spTree>
       <p:nvGrpSpPr>
-        <p:cNvPr id="155" name="Shape 155"/>
+        <p:cNvPr id="157" name="Shape 157"/>
         <p:cNvGrpSpPr/>
         <p:nvPr/>
       </p:nvGrpSpPr>
@@ -1331,7 +1331,7 @@
       </p:grpSpPr>
       <p:sp>
         <p:nvSpPr>
-          <p:cNvPr id="156" name="Google Shape;156;g35da4827f45_0_124:notes"/>
+          <p:cNvPr id="158" name="Google Shape;158;g35da4827f45_0_124:notes"/>
           <p:cNvSpPr/>
           <p:nvPr>
             <p:ph idx="2" type="sldImg"/>
@@ -1366,7 +1366,7 @@
       </p:sp>
       <p:sp>
         <p:nvSpPr>
-          <p:cNvPr id="157" name="Google Shape;157;g35da4827f45_0_124:notes"/>
+          <p:cNvPr id="159" name="Google Shape;159;g35da4827f45_0_124:notes"/>
           <p:cNvSpPr txBox="1"/>
           <p:nvPr>
             <p:ph idx="1" type="body"/>
@@ -1416,7 +1416,7 @@
   <p:cSld>
     <p:spTree>
       <p:nvGrpSpPr>
-        <p:cNvPr id="162" name="Shape 162"/>
+        <p:cNvPr id="164" name="Shape 164"/>
         <p:cNvGrpSpPr/>
         <p:nvPr/>
       </p:nvGrpSpPr>
@@ -1430,7 +1430,7 @@
       </p:grpSpPr>
       <p:sp>
         <p:nvSpPr>
-          <p:cNvPr id="163" name="Google Shape;163;g35da4827f45_0_104:notes"/>
+          <p:cNvPr id="165" name="Google Shape;165;g35da4827f45_0_104:notes"/>
           <p:cNvSpPr/>
           <p:nvPr>
             <p:ph idx="2" type="sldImg"/>
@@ -1465,7 +1465,7 @@
       </p:sp>
       <p:sp>
         <p:nvSpPr>
-          <p:cNvPr id="164" name="Google Shape;164;g35da4827f45_0_104:notes"/>
+          <p:cNvPr id="166" name="Google Shape;166;g35da4827f45_0_104:notes"/>
           <p:cNvSpPr txBox="1"/>
           <p:nvPr>
             <p:ph idx="1" type="body"/>
@@ -1515,7 +1515,7 @@
   <p:cSld>
     <p:spTree>
       <p:nvGrpSpPr>
-        <p:cNvPr id="171" name="Shape 171"/>
+        <p:cNvPr id="173" name="Shape 173"/>
         <p:cNvGrpSpPr/>
         <p:nvPr/>
       </p:nvGrpSpPr>
@@ -1529,7 +1529,7 @@
       </p:grpSpPr>
       <p:sp>
         <p:nvSpPr>
-          <p:cNvPr id="172" name="Google Shape;172;g35da4827f45_0_131:notes"/>
+          <p:cNvPr id="174" name="Google Shape;174;g35da4827f45_0_131:notes"/>
           <p:cNvSpPr/>
           <p:nvPr>
             <p:ph idx="2" type="sldImg"/>
@@ -1564,7 +1564,7 @@
       </p:sp>
       <p:sp>
         <p:nvSpPr>
-          <p:cNvPr id="173" name="Google Shape;173;g35da4827f45_0_131:notes"/>
+          <p:cNvPr id="175" name="Google Shape;175;g35da4827f45_0_131:notes"/>
           <p:cNvSpPr txBox="1"/>
           <p:nvPr>
             <p:ph idx="1" type="body"/>
@@ -1614,7 +1614,7 @@
   <p:cSld>
     <p:spTree>
       <p:nvGrpSpPr>
-        <p:cNvPr id="183" name="Shape 183"/>
+        <p:cNvPr id="185" name="Shape 185"/>
         <p:cNvGrpSpPr/>
         <p:nvPr/>
       </p:nvGrpSpPr>
@@ -1628,7 +1628,7 @@
       </p:grpSpPr>
       <p:sp>
         <p:nvSpPr>
-          <p:cNvPr id="184" name="Google Shape;184;g35da4827f45_0_137:notes"/>
+          <p:cNvPr id="186" name="Google Shape;186;g35da4827f45_0_137:notes"/>
           <p:cNvSpPr/>
           <p:nvPr>
             <p:ph idx="2" type="sldImg"/>
@@ -1663,7 +1663,7 @@
       </p:sp>
       <p:sp>
         <p:nvSpPr>
-          <p:cNvPr id="185" name="Google Shape;185;g35da4827f45_0_137:notes"/>
+          <p:cNvPr id="187" name="Google Shape;187;g35da4827f45_0_137:notes"/>
           <p:cNvSpPr txBox="1"/>
           <p:nvPr>
             <p:ph idx="1" type="body"/>
@@ -1713,7 +1713,7 @@
   <p:cSld>
     <p:spTree>
       <p:nvGrpSpPr>
-        <p:cNvPr id="191" name="Shape 191"/>
+        <p:cNvPr id="193" name="Shape 193"/>
         <p:cNvGrpSpPr/>
         <p:nvPr/>
       </p:nvGrpSpPr>
@@ -1727,7 +1727,7 @@
       </p:grpSpPr>
       <p:sp>
         <p:nvSpPr>
-          <p:cNvPr id="192" name="Google Shape;192;g35da4827f45_0_162:notes"/>
+          <p:cNvPr id="194" name="Google Shape;194;g35da4827f45_0_162:notes"/>
           <p:cNvSpPr/>
           <p:nvPr>
             <p:ph idx="2" type="sldImg"/>
@@ -1762,7 +1762,7 @@
       </p:sp>
       <p:sp>
         <p:nvSpPr>
-          <p:cNvPr id="193" name="Google Shape;193;g35da4827f45_0_162:notes"/>
+          <p:cNvPr id="195" name="Google Shape;195;g35da4827f45_0_162:notes"/>
           <p:cNvSpPr txBox="1"/>
           <p:nvPr>
             <p:ph idx="1" type="body"/>
@@ -1783,7 +1783,7 @@
           </a:bodyPr>
           <a:lstStyle/>
           <a:p>
-            <a:pPr indent="0" lvl="0" marL="0" rtl="0" algn="l">
+            <a:pPr indent="0" lvl="0" marL="0" rtl="1" algn="r">
               <a:spcBef>
                 <a:spcPts val="0"/>
               </a:spcBef>
@@ -1793,7 +1793,8 @@
               <a:buNone/>
             </a:pPr>
             <a:r>
-              <a:t/>
+              <a:rPr lang="iw"/>
+              <a:t>התייחסות לערכי 0 למצב בטריה לא ידוע</a:t>
             </a:r>
             <a:endParaRPr/>
           </a:p>
@@ -1911,7 +1912,7 @@
   <p:cSld>
     <p:spTree>
       <p:nvGrpSpPr>
-        <p:cNvPr id="198" name="Shape 198"/>
+        <p:cNvPr id="200" name="Shape 200"/>
         <p:cNvGrpSpPr/>
         <p:nvPr/>
       </p:nvGrpSpPr>
@@ -1925,7 +1926,7 @@
       </p:grpSpPr>
       <p:sp>
         <p:nvSpPr>
-          <p:cNvPr id="199" name="Google Shape;199;g35da4827f45_0_167:notes"/>
+          <p:cNvPr id="201" name="Google Shape;201;g35da4827f45_0_167:notes"/>
           <p:cNvSpPr/>
           <p:nvPr>
             <p:ph idx="2" type="sldImg"/>
@@ -1960,7 +1961,7 @@
       </p:sp>
       <p:sp>
         <p:nvSpPr>
-          <p:cNvPr id="200" name="Google Shape;200;g35da4827f45_0_167:notes"/>
+          <p:cNvPr id="202" name="Google Shape;202;g35da4827f45_0_167:notes"/>
           <p:cNvSpPr txBox="1"/>
           <p:nvPr>
             <p:ph idx="1" type="body"/>
@@ -2010,7 +2011,7 @@
   <p:cSld>
     <p:spTree>
       <p:nvGrpSpPr>
-        <p:cNvPr id="205" name="Shape 205"/>
+        <p:cNvPr id="207" name="Shape 207"/>
         <p:cNvGrpSpPr/>
         <p:nvPr/>
       </p:nvGrpSpPr>
@@ -2024,7 +2025,7 @@
       </p:grpSpPr>
       <p:sp>
         <p:nvSpPr>
-          <p:cNvPr id="206" name="Google Shape;206;g35da4827f45_0_91:notes"/>
+          <p:cNvPr id="208" name="Google Shape;208;g35da4827f45_0_91:notes"/>
           <p:cNvSpPr/>
           <p:nvPr>
             <p:ph idx="2" type="sldImg"/>
@@ -2059,7 +2060,7 @@
       </p:sp>
       <p:sp>
         <p:nvSpPr>
-          <p:cNvPr id="207" name="Google Shape;207;g35da4827f45_0_91:notes"/>
+          <p:cNvPr id="209" name="Google Shape;209;g35da4827f45_0_91:notes"/>
           <p:cNvSpPr txBox="1"/>
           <p:nvPr>
             <p:ph idx="1" type="body"/>
@@ -2109,7 +2110,7 @@
   <p:cSld>
     <p:spTree>
       <p:nvGrpSpPr>
-        <p:cNvPr id="212" name="Shape 212"/>
+        <p:cNvPr id="214" name="Shape 214"/>
         <p:cNvGrpSpPr/>
         <p:nvPr/>
       </p:nvGrpSpPr>
@@ -2123,7 +2124,7 @@
       </p:grpSpPr>
       <p:sp>
         <p:nvSpPr>
-          <p:cNvPr id="213" name="Google Shape;213;g35da4827f45_2_11:notes"/>
+          <p:cNvPr id="215" name="Google Shape;215;g35da4827f45_2_11:notes"/>
           <p:cNvSpPr/>
           <p:nvPr>
             <p:ph idx="2" type="sldImg"/>
@@ -2158,7 +2159,7 @@
       </p:sp>
       <p:sp>
         <p:nvSpPr>
-          <p:cNvPr id="214" name="Google Shape;214;g35da4827f45_2_11:notes"/>
+          <p:cNvPr id="216" name="Google Shape;216;g35da4827f45_2_11:notes"/>
           <p:cNvSpPr txBox="1"/>
           <p:nvPr>
             <p:ph idx="1" type="body"/>
@@ -2208,7 +2209,7 @@
   <p:cSld>
     <p:spTree>
       <p:nvGrpSpPr>
-        <p:cNvPr id="219" name="Shape 219"/>
+        <p:cNvPr id="221" name="Shape 221"/>
         <p:cNvGrpSpPr/>
         <p:nvPr/>
       </p:nvGrpSpPr>
@@ -2222,7 +2223,7 @@
       </p:grpSpPr>
       <p:sp>
         <p:nvSpPr>
-          <p:cNvPr id="220" name="Google Shape;220;g35da4827f45_2_17:notes"/>
+          <p:cNvPr id="222" name="Google Shape;222;g35da4827f45_2_17:notes"/>
           <p:cNvSpPr/>
           <p:nvPr>
             <p:ph idx="2" type="sldImg"/>
@@ -2257,7 +2258,7 @@
       </p:sp>
       <p:sp>
         <p:nvSpPr>
-          <p:cNvPr id="221" name="Google Shape;221;g35da4827f45_2_17:notes"/>
+          <p:cNvPr id="223" name="Google Shape;223;g35da4827f45_2_17:notes"/>
           <p:cNvSpPr txBox="1"/>
           <p:nvPr>
             <p:ph idx="1" type="body"/>
@@ -2307,7 +2308,7 @@
   <p:cSld>
     <p:spTree>
       <p:nvGrpSpPr>
-        <p:cNvPr id="226" name="Shape 226"/>
+        <p:cNvPr id="228" name="Shape 228"/>
         <p:cNvGrpSpPr/>
         <p:nvPr/>
       </p:nvGrpSpPr>
@@ -2321,7 +2322,7 @@
       </p:grpSpPr>
       <p:sp>
         <p:nvSpPr>
-          <p:cNvPr id="227" name="Google Shape;227;g35da4827f45_0_157:notes"/>
+          <p:cNvPr id="229" name="Google Shape;229;g35da4827f45_0_157:notes"/>
           <p:cNvSpPr/>
           <p:nvPr>
             <p:ph idx="2" type="sldImg"/>
@@ -2356,7 +2357,7 @@
       </p:sp>
       <p:sp>
         <p:nvSpPr>
-          <p:cNvPr id="228" name="Google Shape;228;g35da4827f45_0_157:notes"/>
+          <p:cNvPr id="230" name="Google Shape;230;g35da4827f45_0_157:notes"/>
           <p:cNvSpPr txBox="1"/>
           <p:nvPr>
             <p:ph idx="1" type="body"/>
@@ -2802,7 +2803,7 @@
   <p:cSld>
     <p:spTree>
       <p:nvGrpSpPr>
-        <p:cNvPr id="94" name="Shape 94"/>
+        <p:cNvPr id="95" name="Shape 95"/>
         <p:cNvGrpSpPr/>
         <p:nvPr/>
       </p:nvGrpSpPr>
@@ -2816,7 +2817,7 @@
       </p:grpSpPr>
       <p:sp>
         <p:nvSpPr>
-          <p:cNvPr id="95" name="Google Shape;95;g35da4827f45_0_14:notes"/>
+          <p:cNvPr id="96" name="Google Shape;96;g35da4827f45_0_14:notes"/>
           <p:cNvSpPr/>
           <p:nvPr>
             <p:ph idx="2" type="sldImg"/>
@@ -2851,7 +2852,7 @@
       </p:sp>
       <p:sp>
         <p:nvSpPr>
-          <p:cNvPr id="96" name="Google Shape;96;g35da4827f45_0_14:notes"/>
+          <p:cNvPr id="97" name="Google Shape;97;g35da4827f45_0_14:notes"/>
           <p:cNvSpPr txBox="1"/>
           <p:nvPr>
             <p:ph idx="1" type="body"/>
@@ -2901,7 +2902,7 @@
   <p:cSld>
     <p:spTree>
       <p:nvGrpSpPr>
-        <p:cNvPr id="102" name="Shape 102"/>
+        <p:cNvPr id="104" name="Shape 104"/>
         <p:cNvGrpSpPr/>
         <p:nvPr/>
       </p:nvGrpSpPr>
@@ -2915,7 +2916,7 @@
       </p:grpSpPr>
       <p:sp>
         <p:nvSpPr>
-          <p:cNvPr id="103" name="Google Shape;103;g35da4827f45_2_3:notes"/>
+          <p:cNvPr id="105" name="Google Shape;105;g35da4827f45_2_3:notes"/>
           <p:cNvSpPr/>
           <p:nvPr>
             <p:ph idx="2" type="sldImg"/>
@@ -2950,7 +2951,7 @@
       </p:sp>
       <p:sp>
         <p:nvSpPr>
-          <p:cNvPr id="104" name="Google Shape;104;g35da4827f45_2_3:notes"/>
+          <p:cNvPr id="106" name="Google Shape;106;g35da4827f45_2_3:notes"/>
           <p:cNvSpPr txBox="1"/>
           <p:nvPr>
             <p:ph idx="1" type="body"/>
@@ -3000,7 +3001,7 @@
   <p:cSld>
     <p:spTree>
       <p:nvGrpSpPr>
-        <p:cNvPr id="109" name="Shape 109"/>
+        <p:cNvPr id="111" name="Shape 111"/>
         <p:cNvGrpSpPr/>
         <p:nvPr/>
       </p:nvGrpSpPr>
@@ -3014,7 +3015,7 @@
       </p:grpSpPr>
       <p:sp>
         <p:nvSpPr>
-          <p:cNvPr id="110" name="Google Shape;110;g35da4827f45_0_67:notes"/>
+          <p:cNvPr id="112" name="Google Shape;112;g35da4827f45_0_67:notes"/>
           <p:cNvSpPr/>
           <p:nvPr>
             <p:ph idx="2" type="sldImg"/>
@@ -3049,7 +3050,7 @@
       </p:sp>
       <p:sp>
         <p:nvSpPr>
-          <p:cNvPr id="111" name="Google Shape;111;g35da4827f45_0_67:notes"/>
+          <p:cNvPr id="113" name="Google Shape;113;g35da4827f45_0_67:notes"/>
           <p:cNvSpPr txBox="1"/>
           <p:nvPr>
             <p:ph idx="1" type="body"/>
@@ -8036,7 +8037,7 @@
   <p:cSld>
     <p:spTree>
       <p:nvGrpSpPr>
-        <p:cNvPr id="121" name="Shape 121"/>
+        <p:cNvPr id="123" name="Shape 123"/>
         <p:cNvGrpSpPr/>
         <p:nvPr/>
       </p:nvGrpSpPr>
@@ -8050,7 +8051,7 @@
       </p:grpSpPr>
       <p:sp>
         <p:nvSpPr>
-          <p:cNvPr id="122" name="Google Shape;122;p22"/>
+          <p:cNvPr id="124" name="Google Shape;124;p22"/>
           <p:cNvSpPr txBox="1"/>
           <p:nvPr>
             <p:ph type="title"/>
@@ -8101,7 +8102,7 @@
       </p:sp>
       <p:sp>
         <p:nvSpPr>
-          <p:cNvPr id="123" name="Google Shape;123;p22"/>
+          <p:cNvPr id="125" name="Google Shape;125;p22"/>
           <p:cNvSpPr txBox="1"/>
           <p:nvPr>
             <p:ph idx="1" type="body"/>
@@ -8173,7 +8174,7 @@
       </p:sp>
       <p:pic>
         <p:nvPicPr>
-          <p:cNvPr id="124" name="Google Shape;124;p22"/>
+          <p:cNvPr id="126" name="Google Shape;126;p22"/>
           <p:cNvPicPr preferRelativeResize="0"/>
           <p:nvPr/>
         </p:nvPicPr>
@@ -8201,7 +8202,7 @@
       </p:pic>
       <p:pic>
         <p:nvPicPr>
-          <p:cNvPr id="125" name="Google Shape;125;p22"/>
+          <p:cNvPr id="127" name="Google Shape;127;p22"/>
           <p:cNvPicPr preferRelativeResize="0"/>
           <p:nvPr/>
         </p:nvPicPr>
@@ -8240,7 +8241,7 @@
   <p:cSld>
     <p:spTree>
       <p:nvGrpSpPr>
-        <p:cNvPr id="129" name="Shape 129"/>
+        <p:cNvPr id="131" name="Shape 131"/>
         <p:cNvGrpSpPr/>
         <p:nvPr/>
       </p:nvGrpSpPr>
@@ -8254,7 +8255,7 @@
       </p:grpSpPr>
       <p:sp>
         <p:nvSpPr>
-          <p:cNvPr id="130" name="Google Shape;130;p23"/>
+          <p:cNvPr id="132" name="Google Shape;132;p23"/>
           <p:cNvSpPr txBox="1"/>
           <p:nvPr>
             <p:ph idx="1" type="body"/>
@@ -8294,7 +8295,7 @@
       </p:sp>
       <p:pic>
         <p:nvPicPr>
-          <p:cNvPr id="131" name="Google Shape;131;p23"/>
+          <p:cNvPr id="133" name="Google Shape;133;p23"/>
           <p:cNvPicPr preferRelativeResize="0"/>
           <p:nvPr/>
         </p:nvPicPr>
@@ -8322,7 +8323,7 @@
       </p:pic>
       <p:sp>
         <p:nvSpPr>
-          <p:cNvPr id="132" name="Google Shape;132;p23"/>
+          <p:cNvPr id="134" name="Google Shape;134;p23"/>
           <p:cNvSpPr txBox="1"/>
           <p:nvPr>
             <p:ph type="title"/>
@@ -8387,7 +8388,7 @@
   <p:cSld>
     <p:spTree>
       <p:nvGrpSpPr>
-        <p:cNvPr id="136" name="Shape 136"/>
+        <p:cNvPr id="138" name="Shape 138"/>
         <p:cNvGrpSpPr/>
         <p:nvPr/>
       </p:nvGrpSpPr>
@@ -8401,7 +8402,7 @@
       </p:grpSpPr>
       <p:sp>
         <p:nvSpPr>
-          <p:cNvPr id="137" name="Google Shape;137;p24"/>
+          <p:cNvPr id="139" name="Google Shape;139;p24"/>
           <p:cNvSpPr txBox="1"/>
           <p:nvPr>
             <p:ph type="title"/>
@@ -8441,7 +8442,7 @@
       </p:sp>
       <p:sp>
         <p:nvSpPr>
-          <p:cNvPr id="138" name="Google Shape;138;p24"/>
+          <p:cNvPr id="140" name="Google Shape;140;p24"/>
           <p:cNvSpPr txBox="1"/>
           <p:nvPr>
             <p:ph idx="1" type="body"/>
@@ -8504,7 +8505,7 @@
       </p:sp>
       <p:pic>
         <p:nvPicPr>
-          <p:cNvPr id="139" name="Google Shape;139;p24"/>
+          <p:cNvPr id="141" name="Google Shape;141;p24"/>
           <p:cNvPicPr preferRelativeResize="0"/>
           <p:nvPr/>
         </p:nvPicPr>
@@ -8543,7 +8544,7 @@
   <p:cSld>
     <p:spTree>
       <p:nvGrpSpPr>
-        <p:cNvPr id="143" name="Shape 143"/>
+        <p:cNvPr id="145" name="Shape 145"/>
         <p:cNvGrpSpPr/>
         <p:nvPr/>
       </p:nvGrpSpPr>
@@ -8557,7 +8558,7 @@
       </p:grpSpPr>
       <p:sp>
         <p:nvSpPr>
-          <p:cNvPr id="144" name="Google Shape;144;p25"/>
+          <p:cNvPr id="146" name="Google Shape;146;p25"/>
           <p:cNvSpPr txBox="1"/>
           <p:nvPr>
             <p:ph type="title"/>
@@ -8597,7 +8598,7 @@
       </p:sp>
       <p:sp>
         <p:nvSpPr>
-          <p:cNvPr id="145" name="Google Shape;145;p25"/>
+          <p:cNvPr id="147" name="Google Shape;147;p25"/>
           <p:cNvSpPr txBox="1"/>
           <p:nvPr>
             <p:ph idx="1" type="body"/>
@@ -8653,7 +8654,7 @@
       </p:sp>
       <p:pic>
         <p:nvPicPr>
-          <p:cNvPr id="146" name="Google Shape;146;p25"/>
+          <p:cNvPr id="148" name="Google Shape;148;p25"/>
           <p:cNvPicPr preferRelativeResize="0"/>
           <p:nvPr/>
         </p:nvPicPr>
@@ -8681,7 +8682,7 @@
       </p:pic>
       <p:pic>
         <p:nvPicPr>
-          <p:cNvPr id="147" name="Google Shape;147;p25"/>
+          <p:cNvPr id="149" name="Google Shape;149;p25"/>
           <p:cNvPicPr preferRelativeResize="0"/>
           <p:nvPr/>
         </p:nvPicPr>
@@ -8720,7 +8721,7 @@
   <p:cSld>
     <p:spTree>
       <p:nvGrpSpPr>
-        <p:cNvPr id="151" name="Shape 151"/>
+        <p:cNvPr id="153" name="Shape 153"/>
         <p:cNvGrpSpPr/>
         <p:nvPr/>
       </p:nvGrpSpPr>
@@ -8734,7 +8735,7 @@
       </p:grpSpPr>
       <p:sp>
         <p:nvSpPr>
-          <p:cNvPr id="152" name="Google Shape;152;p26"/>
+          <p:cNvPr id="154" name="Google Shape;154;p26"/>
           <p:cNvSpPr txBox="1"/>
           <p:nvPr>
             <p:ph type="title"/>
@@ -8774,7 +8775,7 @@
       </p:sp>
       <p:sp>
         <p:nvSpPr>
-          <p:cNvPr id="153" name="Google Shape;153;p26"/>
+          <p:cNvPr id="155" name="Google Shape;155;p26"/>
           <p:cNvSpPr txBox="1"/>
           <p:nvPr>
             <p:ph idx="1" type="body"/>
@@ -8835,7 +8836,7 @@
       </p:sp>
       <p:pic>
         <p:nvPicPr>
-          <p:cNvPr id="154" name="Google Shape;154;p26"/>
+          <p:cNvPr id="156" name="Google Shape;156;p26"/>
           <p:cNvPicPr preferRelativeResize="0"/>
           <p:nvPr/>
         </p:nvPicPr>
@@ -8874,7 +8875,7 @@
   <p:cSld>
     <p:spTree>
       <p:nvGrpSpPr>
-        <p:cNvPr id="158" name="Shape 158"/>
+        <p:cNvPr id="160" name="Shape 160"/>
         <p:cNvGrpSpPr/>
         <p:nvPr/>
       </p:nvGrpSpPr>
@@ -8888,7 +8889,7 @@
       </p:grpSpPr>
       <p:sp>
         <p:nvSpPr>
-          <p:cNvPr id="159" name="Google Shape;159;p27"/>
+          <p:cNvPr id="161" name="Google Shape;161;p27"/>
           <p:cNvSpPr txBox="1"/>
           <p:nvPr>
             <p:ph type="title"/>
@@ -8928,7 +8929,7 @@
       </p:sp>
       <p:sp>
         <p:nvSpPr>
-          <p:cNvPr id="160" name="Google Shape;160;p27"/>
+          <p:cNvPr id="162" name="Google Shape;162;p27"/>
           <p:cNvSpPr txBox="1"/>
           <p:nvPr>
             <p:ph idx="1" type="body"/>
@@ -8984,7 +8985,7 @@
       </p:sp>
       <p:pic>
         <p:nvPicPr>
-          <p:cNvPr id="161" name="Google Shape;161;p27"/>
+          <p:cNvPr id="163" name="Google Shape;163;p27"/>
           <p:cNvPicPr preferRelativeResize="0"/>
           <p:nvPr/>
         </p:nvPicPr>
@@ -9023,7 +9024,7 @@
   <p:cSld>
     <p:spTree>
       <p:nvGrpSpPr>
-        <p:cNvPr id="165" name="Shape 165"/>
+        <p:cNvPr id="167" name="Shape 167"/>
         <p:cNvGrpSpPr/>
         <p:nvPr/>
       </p:nvGrpSpPr>
@@ -9037,7 +9038,7 @@
       </p:grpSpPr>
       <p:sp>
         <p:nvSpPr>
-          <p:cNvPr id="166" name="Google Shape;166;p28"/>
+          <p:cNvPr id="168" name="Google Shape;168;p28"/>
           <p:cNvSpPr txBox="1"/>
           <p:nvPr>
             <p:ph type="title"/>
@@ -9077,7 +9078,7 @@
       </p:sp>
       <p:sp>
         <p:nvSpPr>
-          <p:cNvPr id="167" name="Google Shape;167;p28"/>
+          <p:cNvPr id="169" name="Google Shape;169;p28"/>
           <p:cNvSpPr txBox="1"/>
           <p:nvPr>
             <p:ph idx="1" type="body"/>
@@ -9168,7 +9169,7 @@
       </p:sp>
       <p:pic>
         <p:nvPicPr>
-          <p:cNvPr id="168" name="Google Shape;168;p28"/>
+          <p:cNvPr id="170" name="Google Shape;170;p28"/>
           <p:cNvPicPr preferRelativeResize="0"/>
           <p:nvPr/>
         </p:nvPicPr>
@@ -9196,7 +9197,7 @@
       </p:pic>
       <p:pic>
         <p:nvPicPr>
-          <p:cNvPr id="169" name="Google Shape;169;p28"/>
+          <p:cNvPr id="171" name="Google Shape;171;p28"/>
           <p:cNvPicPr preferRelativeResize="0"/>
           <p:nvPr/>
         </p:nvPicPr>
@@ -9224,7 +9225,7 @@
       </p:pic>
       <p:pic>
         <p:nvPicPr>
-          <p:cNvPr id="170" name="Google Shape;170;p28"/>
+          <p:cNvPr id="172" name="Google Shape;172;p28"/>
           <p:cNvPicPr preferRelativeResize="0"/>
           <p:nvPr/>
         </p:nvPicPr>
@@ -9263,7 +9264,7 @@
   <p:cSld>
     <p:spTree>
       <p:nvGrpSpPr>
-        <p:cNvPr id="174" name="Shape 174"/>
+        <p:cNvPr id="176" name="Shape 176"/>
         <p:cNvGrpSpPr/>
         <p:nvPr/>
       </p:nvGrpSpPr>
@@ -9277,7 +9278,7 @@
       </p:grpSpPr>
       <p:sp>
         <p:nvSpPr>
-          <p:cNvPr id="175" name="Google Shape;175;p29"/>
+          <p:cNvPr id="177" name="Google Shape;177;p29"/>
           <p:cNvSpPr txBox="1"/>
           <p:nvPr>
             <p:ph type="title"/>
@@ -9321,7 +9322,7 @@
       </p:sp>
       <p:sp>
         <p:nvSpPr>
-          <p:cNvPr id="176" name="Google Shape;176;p29"/>
+          <p:cNvPr id="178" name="Google Shape;178;p29"/>
           <p:cNvSpPr txBox="1"/>
           <p:nvPr>
             <p:ph idx="1" type="body"/>
@@ -9369,7 +9370,7 @@
       </p:sp>
       <p:pic>
         <p:nvPicPr>
-          <p:cNvPr id="177" name="Google Shape;177;p29"/>
+          <p:cNvPr id="179" name="Google Shape;179;p29"/>
           <p:cNvPicPr preferRelativeResize="0"/>
           <p:nvPr/>
         </p:nvPicPr>
@@ -9397,7 +9398,7 @@
       </p:pic>
       <p:sp>
         <p:nvSpPr>
-          <p:cNvPr id="178" name="Google Shape;178;p29"/>
+          <p:cNvPr id="180" name="Google Shape;180;p29"/>
           <p:cNvSpPr txBox="1"/>
           <p:nvPr>
             <p:ph idx="1" type="body"/>
@@ -9441,7 +9442,7 @@
       </p:sp>
       <p:pic>
         <p:nvPicPr>
-          <p:cNvPr id="179" name="Google Shape;179;p29"/>
+          <p:cNvPr id="181" name="Google Shape;181;p29"/>
           <p:cNvPicPr preferRelativeResize="0"/>
           <p:nvPr/>
         </p:nvPicPr>
@@ -9469,7 +9470,7 @@
       </p:pic>
       <p:pic>
         <p:nvPicPr>
-          <p:cNvPr id="180" name="Google Shape;180;p29"/>
+          <p:cNvPr id="182" name="Google Shape;182;p29"/>
           <p:cNvPicPr preferRelativeResize="0"/>
           <p:nvPr/>
         </p:nvPicPr>
@@ -9497,7 +9498,7 @@
       </p:pic>
       <p:sp>
         <p:nvSpPr>
-          <p:cNvPr id="181" name="Google Shape;181;p29"/>
+          <p:cNvPr id="183" name="Google Shape;183;p29"/>
           <p:cNvSpPr txBox="1"/>
           <p:nvPr>
             <p:ph idx="1" type="body"/>
@@ -9533,7 +9534,7 @@
             </a:pPr>
             <a:r>
               <a:rPr lang="iw" sz="1300"/>
-              <a:t>And that TESLA is actually tied with FORD in Columbia</a:t>
+              <a:t>And TESLA is actually tied with FORD in Columbia</a:t>
             </a:r>
             <a:endParaRPr sz="1420"/>
           </a:p>
@@ -9541,7 +9542,7 @@
       </p:sp>
       <p:pic>
         <p:nvPicPr>
-          <p:cNvPr id="182" name="Google Shape;182;p29"/>
+          <p:cNvPr id="184" name="Google Shape;184;p29"/>
           <p:cNvPicPr preferRelativeResize="0"/>
           <p:nvPr/>
         </p:nvPicPr>
@@ -9580,7 +9581,7 @@
   <p:cSld>
     <p:spTree>
       <p:nvGrpSpPr>
-        <p:cNvPr id="186" name="Shape 186"/>
+        <p:cNvPr id="188" name="Shape 188"/>
         <p:cNvGrpSpPr/>
         <p:nvPr/>
       </p:nvGrpSpPr>
@@ -9594,7 +9595,7 @@
       </p:grpSpPr>
       <p:sp>
         <p:nvSpPr>
-          <p:cNvPr id="187" name="Google Shape;187;p30"/>
+          <p:cNvPr id="189" name="Google Shape;189;p30"/>
           <p:cNvSpPr txBox="1"/>
           <p:nvPr>
             <p:ph type="title"/>
@@ -9634,7 +9635,7 @@
       </p:sp>
       <p:sp>
         <p:nvSpPr>
-          <p:cNvPr id="188" name="Google Shape;188;p30"/>
+          <p:cNvPr id="190" name="Google Shape;190;p30"/>
           <p:cNvSpPr txBox="1"/>
           <p:nvPr>
             <p:ph idx="1" type="body"/>
@@ -9686,7 +9687,7 @@
       </p:sp>
       <p:pic>
         <p:nvPicPr>
-          <p:cNvPr id="189" name="Google Shape;189;p30"/>
+          <p:cNvPr id="191" name="Google Shape;191;p30"/>
           <p:cNvPicPr preferRelativeResize="0"/>
           <p:nvPr/>
         </p:nvPicPr>
@@ -9714,7 +9715,7 @@
       </p:pic>
       <p:pic>
         <p:nvPicPr>
-          <p:cNvPr id="190" name="Google Shape;190;p30"/>
+          <p:cNvPr id="192" name="Google Shape;192;p30"/>
           <p:cNvPicPr preferRelativeResize="0"/>
           <p:nvPr/>
         </p:nvPicPr>
@@ -9753,7 +9754,7 @@
   <p:cSld>
     <p:spTree>
       <p:nvGrpSpPr>
-        <p:cNvPr id="194" name="Shape 194"/>
+        <p:cNvPr id="196" name="Shape 196"/>
         <p:cNvGrpSpPr/>
         <p:nvPr/>
       </p:nvGrpSpPr>
@@ -9767,7 +9768,7 @@
       </p:grpSpPr>
       <p:sp>
         <p:nvSpPr>
-          <p:cNvPr id="195" name="Google Shape;195;p31"/>
+          <p:cNvPr id="197" name="Google Shape;197;p31"/>
           <p:cNvSpPr txBox="1"/>
           <p:nvPr>
             <p:ph type="title"/>
@@ -9807,7 +9808,7 @@
       </p:sp>
       <p:sp>
         <p:nvSpPr>
-          <p:cNvPr id="196" name="Google Shape;196;p31"/>
+          <p:cNvPr id="198" name="Google Shape;198;p31"/>
           <p:cNvSpPr txBox="1"/>
           <p:nvPr>
             <p:ph idx="1" type="body"/>
@@ -9906,7 +9907,7 @@
       </p:sp>
       <p:pic>
         <p:nvPicPr>
-          <p:cNvPr id="197" name="Google Shape;197;p31"/>
+          <p:cNvPr id="199" name="Google Shape;199;p31"/>
           <p:cNvPicPr preferRelativeResize="0"/>
           <p:nvPr/>
         </p:nvPicPr>
@@ -10164,7 +10165,7 @@
   <p:cSld>
     <p:spTree>
       <p:nvGrpSpPr>
-        <p:cNvPr id="201" name="Shape 201"/>
+        <p:cNvPr id="203" name="Shape 203"/>
         <p:cNvGrpSpPr/>
         <p:nvPr/>
       </p:nvGrpSpPr>
@@ -10178,7 +10179,7 @@
       </p:grpSpPr>
       <p:sp>
         <p:nvSpPr>
-          <p:cNvPr id="202" name="Google Shape;202;p32"/>
+          <p:cNvPr id="204" name="Google Shape;204;p32"/>
           <p:cNvSpPr txBox="1"/>
           <p:nvPr>
             <p:ph type="title"/>
@@ -10218,7 +10219,7 @@
       </p:sp>
       <p:sp>
         <p:nvSpPr>
-          <p:cNvPr id="203" name="Google Shape;203;p32"/>
+          <p:cNvPr id="205" name="Google Shape;205;p32"/>
           <p:cNvSpPr txBox="1"/>
           <p:nvPr>
             <p:ph idx="1" type="body"/>
@@ -10325,7 +10326,7 @@
       </p:sp>
       <p:pic>
         <p:nvPicPr>
-          <p:cNvPr id="204" name="Google Shape;204;p32"/>
+          <p:cNvPr id="206" name="Google Shape;206;p32"/>
           <p:cNvPicPr preferRelativeResize="0"/>
           <p:nvPr/>
         </p:nvPicPr>
@@ -10364,7 +10365,7 @@
   <p:cSld>
     <p:spTree>
       <p:nvGrpSpPr>
-        <p:cNvPr id="208" name="Shape 208"/>
+        <p:cNvPr id="210" name="Shape 210"/>
         <p:cNvGrpSpPr/>
         <p:nvPr/>
       </p:nvGrpSpPr>
@@ -10378,7 +10379,7 @@
       </p:grpSpPr>
       <p:sp>
         <p:nvSpPr>
-          <p:cNvPr id="209" name="Google Shape;209;p33"/>
+          <p:cNvPr id="211" name="Google Shape;211;p33"/>
           <p:cNvSpPr txBox="1"/>
           <p:nvPr>
             <p:ph type="title"/>
@@ -10418,7 +10419,7 @@
       </p:sp>
       <p:sp>
         <p:nvSpPr>
-          <p:cNvPr id="210" name="Google Shape;210;p33"/>
+          <p:cNvPr id="212" name="Google Shape;212;p33"/>
           <p:cNvSpPr txBox="1"/>
           <p:nvPr>
             <p:ph idx="1" type="body"/>
@@ -10470,7 +10471,7 @@
       </p:sp>
       <p:pic>
         <p:nvPicPr>
-          <p:cNvPr id="211" name="Google Shape;211;p33"/>
+          <p:cNvPr id="213" name="Google Shape;213;p33"/>
           <p:cNvPicPr preferRelativeResize="0"/>
           <p:nvPr/>
         </p:nvPicPr>
@@ -10509,7 +10510,7 @@
   <p:cSld>
     <p:spTree>
       <p:nvGrpSpPr>
-        <p:cNvPr id="215" name="Shape 215"/>
+        <p:cNvPr id="217" name="Shape 217"/>
         <p:cNvGrpSpPr/>
         <p:nvPr/>
       </p:nvGrpSpPr>
@@ -10523,7 +10524,7 @@
       </p:grpSpPr>
       <p:sp>
         <p:nvSpPr>
-          <p:cNvPr id="216" name="Google Shape;216;p34"/>
+          <p:cNvPr id="218" name="Google Shape;218;p34"/>
           <p:cNvSpPr txBox="1"/>
           <p:nvPr>
             <p:ph type="title"/>
@@ -10567,7 +10568,7 @@
       </p:sp>
       <p:sp>
         <p:nvSpPr>
-          <p:cNvPr id="217" name="Google Shape;217;p34"/>
+          <p:cNvPr id="219" name="Google Shape;219;p34"/>
           <p:cNvSpPr txBox="1"/>
           <p:nvPr>
             <p:ph idx="1" type="body"/>
@@ -10607,7 +10608,7 @@
       </p:sp>
       <p:pic>
         <p:nvPicPr>
-          <p:cNvPr id="218" name="Google Shape;218;p34"/>
+          <p:cNvPr id="220" name="Google Shape;220;p34"/>
           <p:cNvPicPr preferRelativeResize="0"/>
           <p:nvPr/>
         </p:nvPicPr>
@@ -10646,7 +10647,7 @@
   <p:cSld>
     <p:spTree>
       <p:nvGrpSpPr>
-        <p:cNvPr id="222" name="Shape 222"/>
+        <p:cNvPr id="224" name="Shape 224"/>
         <p:cNvGrpSpPr/>
         <p:nvPr/>
       </p:nvGrpSpPr>
@@ -10660,7 +10661,7 @@
       </p:grpSpPr>
       <p:sp>
         <p:nvSpPr>
-          <p:cNvPr id="223" name="Google Shape;223;p35"/>
+          <p:cNvPr id="225" name="Google Shape;225;p35"/>
           <p:cNvSpPr txBox="1"/>
           <p:nvPr>
             <p:ph type="title"/>
@@ -10700,7 +10701,7 @@
       </p:sp>
       <p:sp>
         <p:nvSpPr>
-          <p:cNvPr id="224" name="Google Shape;224;p35"/>
+          <p:cNvPr id="226" name="Google Shape;226;p35"/>
           <p:cNvSpPr txBox="1"/>
           <p:nvPr>
             <p:ph idx="1" type="body"/>
@@ -10740,7 +10741,7 @@
       </p:sp>
       <p:pic>
         <p:nvPicPr>
-          <p:cNvPr id="225" name="Google Shape;225;p35"/>
+          <p:cNvPr id="227" name="Google Shape;227;p35"/>
           <p:cNvPicPr preferRelativeResize="0"/>
           <p:nvPr/>
         </p:nvPicPr>
@@ -10779,7 +10780,7 @@
   <p:cSld>
     <p:spTree>
       <p:nvGrpSpPr>
-        <p:cNvPr id="229" name="Shape 229"/>
+        <p:cNvPr id="231" name="Shape 231"/>
         <p:cNvGrpSpPr/>
         <p:nvPr/>
       </p:nvGrpSpPr>
@@ -10793,7 +10794,7 @@
       </p:grpSpPr>
       <p:sp>
         <p:nvSpPr>
-          <p:cNvPr id="230" name="Google Shape;230;p36"/>
+          <p:cNvPr id="232" name="Google Shape;232;p36"/>
           <p:cNvSpPr txBox="1"/>
           <p:nvPr>
             <p:ph type="title"/>
@@ -10833,7 +10834,7 @@
       </p:sp>
       <p:pic>
         <p:nvPicPr>
-          <p:cNvPr id="231" name="Google Shape;231;p36"/>
+          <p:cNvPr id="233" name="Google Shape;233;p36"/>
           <p:cNvPicPr preferRelativeResize="0"/>
           <p:nvPr/>
         </p:nvPicPr>
@@ -11170,7 +11171,7 @@
             <a:tbl>
               <a:tblPr>
                 <a:noFill/>
-                <a:tableStyleId>{A1A136FA-2B72-4651-A519-8C62079C87FA}</a:tableStyleId>
+                <a:tableStyleId>{2A01AFC5-6646-4A61-BB2E-F47871C702AD}</a:tableStyleId>
               </a:tblPr>
               <a:tblGrid>
                 <a:gridCol w="2019075"/>
@@ -11974,7 +11975,7 @@
             <a:tbl>
               <a:tblPr>
                 <a:noFill/>
-                <a:tableStyleId>{A1A136FA-2B72-4651-A519-8C62079C87FA}</a:tableStyleId>
+                <a:tableStyleId>{2A01AFC5-6646-4A61-BB2E-F47871C702AD}</a:tableStyleId>
               </a:tblPr>
               <a:tblGrid>
                 <a:gridCol w="2019050"/>
@@ -12845,8 +12846,36 @@
         </p:blipFill>
         <p:spPr>
           <a:xfrm>
-            <a:off x="476025" y="4206000"/>
+            <a:off x="476025" y="3501250"/>
             <a:ext cx="8520601" cy="688000"/>
+          </a:xfrm>
+          <a:prstGeom prst="rect">
+            <a:avLst/>
+          </a:prstGeom>
+          <a:noFill/>
+          <a:ln>
+            <a:noFill/>
+          </a:ln>
+        </p:spPr>
+      </p:pic>
+      <p:pic>
+        <p:nvPicPr>
+          <p:cNvPr id="94" name="Google Shape;94;p18"/>
+          <p:cNvPicPr preferRelativeResize="0"/>
+          <p:nvPr/>
+        </p:nvPicPr>
+        <p:blipFill>
+          <a:blip r:embed="rId4">
+            <a:alphaModFix/>
+          </a:blip>
+          <a:stretch>
+            <a:fillRect/>
+          </a:stretch>
+        </p:blipFill>
+        <p:spPr>
+          <a:xfrm>
+            <a:off x="3152980" y="4288175"/>
+            <a:ext cx="2838047" cy="572700"/>
           </a:xfrm>
           <a:prstGeom prst="rect">
             <a:avLst/>
@@ -12870,7 +12899,7 @@
   <p:cSld>
     <p:spTree>
       <p:nvGrpSpPr>
-        <p:cNvPr id="97" name="Shape 97"/>
+        <p:cNvPr id="98" name="Shape 98"/>
         <p:cNvGrpSpPr/>
         <p:nvPr/>
       </p:nvGrpSpPr>
@@ -12884,7 +12913,7 @@
       </p:grpSpPr>
       <p:sp>
         <p:nvSpPr>
-          <p:cNvPr id="98" name="Google Shape;98;p19"/>
+          <p:cNvPr id="99" name="Google Shape;99;p19"/>
           <p:cNvSpPr txBox="1"/>
           <p:nvPr>
             <p:ph type="title"/>
@@ -12924,7 +12953,7 @@
       </p:sp>
       <p:sp>
         <p:nvSpPr>
-          <p:cNvPr id="99" name="Google Shape;99;p19"/>
+          <p:cNvPr id="100" name="Google Shape;100;p19"/>
           <p:cNvSpPr txBox="1"/>
           <p:nvPr>
             <p:ph idx="1" type="body"/>
@@ -12999,7 +13028,7 @@
       </p:sp>
       <p:pic>
         <p:nvPicPr>
-          <p:cNvPr id="100" name="Google Shape;100;p19"/>
+          <p:cNvPr id="101" name="Google Shape;101;p19"/>
           <p:cNvPicPr preferRelativeResize="0"/>
           <p:nvPr/>
         </p:nvPicPr>
@@ -13027,7 +13056,7 @@
       </p:pic>
       <p:pic>
         <p:nvPicPr>
-          <p:cNvPr id="101" name="Google Shape;101;p19"/>
+          <p:cNvPr id="102" name="Google Shape;102;p19"/>
           <p:cNvPicPr preferRelativeResize="0"/>
           <p:nvPr/>
         </p:nvPicPr>
@@ -13042,7 +13071,35 @@
         <p:spPr>
           <a:xfrm>
             <a:off x="67575" y="4310650"/>
-            <a:ext cx="8934252" cy="721825"/>
+            <a:ext cx="5846000" cy="472325"/>
+          </a:xfrm>
+          <a:prstGeom prst="rect">
+            <a:avLst/>
+          </a:prstGeom>
+          <a:noFill/>
+          <a:ln>
+            <a:noFill/>
+          </a:ln>
+        </p:spPr>
+      </p:pic>
+      <p:pic>
+        <p:nvPicPr>
+          <p:cNvPr id="103" name="Google Shape;103;p19"/>
+          <p:cNvPicPr preferRelativeResize="0"/>
+          <p:nvPr/>
+        </p:nvPicPr>
+        <p:blipFill>
+          <a:blip r:embed="rId5">
+            <a:alphaModFix/>
+          </a:blip>
+          <a:stretch>
+            <a:fillRect/>
+          </a:stretch>
+        </p:blipFill>
+        <p:spPr>
+          <a:xfrm>
+            <a:off x="6337713" y="4299174"/>
+            <a:ext cx="2076450" cy="495300"/>
           </a:xfrm>
           <a:prstGeom prst="rect">
             <a:avLst/>
@@ -13066,7 +13123,7 @@
   <p:cSld>
     <p:spTree>
       <p:nvGrpSpPr>
-        <p:cNvPr id="105" name="Shape 105"/>
+        <p:cNvPr id="107" name="Shape 107"/>
         <p:cNvGrpSpPr/>
         <p:nvPr/>
       </p:nvGrpSpPr>
@@ -13080,7 +13137,7 @@
       </p:grpSpPr>
       <p:sp>
         <p:nvSpPr>
-          <p:cNvPr id="106" name="Google Shape;106;p20"/>
+          <p:cNvPr id="108" name="Google Shape;108;p20"/>
           <p:cNvSpPr txBox="1"/>
           <p:nvPr>
             <p:ph type="title"/>
@@ -13120,7 +13177,7 @@
       </p:sp>
       <p:sp>
         <p:nvSpPr>
-          <p:cNvPr id="107" name="Google Shape;107;p20"/>
+          <p:cNvPr id="109" name="Google Shape;109;p20"/>
           <p:cNvSpPr txBox="1"/>
           <p:nvPr>
             <p:ph idx="1" type="body"/>
@@ -13556,7 +13613,7 @@
       </p:sp>
       <p:sp>
         <p:nvSpPr>
-          <p:cNvPr id="108" name="Google Shape;108;p20"/>
+          <p:cNvPr id="110" name="Google Shape;110;p20"/>
           <p:cNvSpPr txBox="1"/>
           <p:nvPr/>
         </p:nvSpPr>
@@ -13756,7 +13813,7 @@
   <p:cSld>
     <p:spTree>
       <p:nvGrpSpPr>
-        <p:cNvPr id="112" name="Shape 112"/>
+        <p:cNvPr id="114" name="Shape 114"/>
         <p:cNvGrpSpPr/>
         <p:nvPr/>
       </p:nvGrpSpPr>
@@ -13770,7 +13827,7 @@
       </p:grpSpPr>
       <p:sp>
         <p:nvSpPr>
-          <p:cNvPr id="113" name="Google Shape;113;p21"/>
+          <p:cNvPr id="115" name="Google Shape;115;p21"/>
           <p:cNvSpPr txBox="1"/>
           <p:nvPr>
             <p:ph type="title"/>
@@ -13810,7 +13867,7 @@
       </p:sp>
       <p:sp>
         <p:nvSpPr>
-          <p:cNvPr id="114" name="Google Shape;114;p21"/>
+          <p:cNvPr id="116" name="Google Shape;116;p21"/>
           <p:cNvSpPr txBox="1"/>
           <p:nvPr>
             <p:ph idx="1" type="body"/>
@@ -13857,7 +13914,7 @@
       </p:sp>
       <p:pic>
         <p:nvPicPr>
-          <p:cNvPr id="115" name="Google Shape;115;p21"/>
+          <p:cNvPr id="117" name="Google Shape;117;p21"/>
           <p:cNvPicPr preferRelativeResize="0"/>
           <p:nvPr/>
         </p:nvPicPr>
@@ -13885,7 +13942,7 @@
       </p:pic>
       <p:sp>
         <p:nvSpPr>
-          <p:cNvPr id="116" name="Google Shape;116;p21"/>
+          <p:cNvPr id="118" name="Google Shape;118;p21"/>
           <p:cNvSpPr txBox="1"/>
           <p:nvPr/>
         </p:nvSpPr>
@@ -13935,7 +13992,7 @@
       </p:sp>
       <p:pic>
         <p:nvPicPr>
-          <p:cNvPr id="117" name="Google Shape;117;p21"/>
+          <p:cNvPr id="119" name="Google Shape;119;p21"/>
           <p:cNvPicPr preferRelativeResize="0"/>
           <p:nvPr/>
         </p:nvPicPr>

</xml_diff>